<commit_message>
Rebuild deck with team names
</commit_message>
<xml_diff>
--- a/presentation/SilentHeat.pptx
+++ b/presentation/SilentHeat.pptx
@@ -5509,7 +5509,7 @@
         <p:spPr>
           <a:xfrm>
             <a:off x="6949440" y="1143000"/>
-            <a:ext cx="4572000" cy="731520"/>
+            <a:ext cx="4572000" cy="1188720"/>
           </a:xfrm>
           <a:prstGeom prst="rect">
             <a:avLst/>
@@ -5524,7 +5524,7 @@
           <a:p>
             <a:pPr algn="r">
               <a:lnSpc>
-                <a:spcPct val="112000"/>
+                <a:spcPct val="125000"/>
               </a:lnSpc>
               <a:spcAft>
                 <a:spcPts val="0"/>
@@ -5538,6 +5538,44 @@
                 <a:latin typeface="Poppins Light"/>
               </a:rPr>
               <a:t>ARHAANSH JHINGAN 25BCE0541 (SCOPE)</a:t>
+            </a:r>
+          </a:p>
+          <a:p>
+            <a:pPr algn="r">
+              <a:lnSpc>
+                <a:spcPct val="125000"/>
+              </a:lnSpc>
+              <a:spcAft>
+                <a:spcPts val="0"/>
+              </a:spcAft>
+            </a:pPr>
+            <a:r>
+              <a:rPr sz="1500" b="0" i="0">
+                <a:solidFill>
+                  <a:srgbClr val="F2F2F2"/>
+                </a:solidFill>
+                <a:latin typeface="Poppins Light"/>
+              </a:rPr>
+              <a:t>TVESHA RATHI 25BCE2001</a:t>
+            </a:r>
+          </a:p>
+          <a:p>
+            <a:pPr algn="r">
+              <a:lnSpc>
+                <a:spcPct val="125000"/>
+              </a:lnSpc>
+              <a:spcAft>
+                <a:spcPts val="0"/>
+              </a:spcAft>
+            </a:pPr>
+            <a:r>
+              <a:rPr sz="1500" b="0" i="0">
+                <a:solidFill>
+                  <a:srgbClr val="F2F2F2"/>
+                </a:solidFill>
+                <a:latin typeface="Poppins Light"/>
+              </a:rPr>
+              <a:t>LAKSH RAJA 25BCE0161</a:t>
             </a:r>
           </a:p>
         </p:txBody>

</xml_diff>